<commit_message>
Publicacion en GitHub, link en los entregables y verificador de rubrica
- Se agrega el link del repositorio al README, al informe y a la portada de la
  presentacion. Era el entregable que faltaba segun la guia del curso, que pide
  versionar en GitHub porque las contribuciones se usan para la evaluacion
  individual de cada integrante.
- scripts/verificar_rubrica.py: comprueba sobre el propio notebook los 21
  criterios de la rubrica, cuatro salvaguardas metodologicas y que ninguna celda
  haya quedado sin ejecutar. Sale con codigo 1 si algo falta.
- Informe y presentacion regenerados con el link incluido.

Verificado: el notebook se regenera identico desde un clon limpio (84 celdas,
fuentes iguales) y ningun CSV del reto quedo versionado.
</commit_message>
<xml_diff>
--- a/docs/Proyecto2_Presentacion.pptx
+++ b/docs/Proyecto2_Presentacion.pptx
@@ -3176,6 +3176,18 @@
             </a:pPr>
             <a:r>
               <a:t>Integrantes: ______________________</a:t>
+            </a:r>
+          </a:p>
+          <a:p>
+            <a:pPr>
+              <a:defRPr sz="1200">
+                <a:solidFill>
+                  <a:srgbClr val="0F6E63"/>
+                </a:solidFill>
+              </a:defRPr>
+            </a:pPr>
+            <a:r>
+              <a:t>https://github.com/Javiervalladares1/CC3084-Proyecto2-Drought-EDA</a:t>
             </a:r>
           </a:p>
         </p:txBody>

</xml_diff>